<commit_message>
data collected and minor updates
</commit_message>
<xml_diff>
--- a/AIA_Architecte_Intelligence_Artificielle/Presentations_certification/ppt_versions/Bloc2_AIA_Loic_Valentini.pptx
+++ b/AIA_Architecte_Intelligence_Artificielle/Presentations_certification/ppt_versions/Bloc2_AIA_Loic_Valentini.pptx
@@ -7531,41 +7531,12 @@
       </p:grpSpPr>
       <p:pic>
         <p:nvPicPr>
-          <p:cNvPr id="16" name="Image 15">
-            <a:extLst>
-              <a:ext uri="{FF2B5EF4-FFF2-40B4-BE49-F238E27FC236}">
-                <a16:creationId xmlns:a16="http://schemas.microsoft.com/office/drawing/2014/main" id="{0E52B909-FABA-7B4D-B14F-CEECD697EE58}"/>
-              </a:ext>
-            </a:extLst>
-          </p:cNvPr>
-          <p:cNvPicPr>
-            <a:picLocks noChangeAspect="1"/>
-          </p:cNvPicPr>
-          <p:nvPr/>
-        </p:nvPicPr>
-        <p:blipFill>
-          <a:blip r:embed="rId3"/>
-          <a:srcRect t="1322"/>
-          <a:stretch/>
-        </p:blipFill>
-        <p:spPr>
-          <a:xfrm>
-            <a:off x="424561" y="161841"/>
-            <a:ext cx="8152893" cy="4531088"/>
-          </a:xfrm>
-          <a:prstGeom prst="rect">
-            <a:avLst/>
-          </a:prstGeom>
-        </p:spPr>
-      </p:pic>
-      <p:pic>
-        <p:nvPicPr>
           <p:cNvPr id="75" name="Google Shape;75;p15"/>
           <p:cNvPicPr preferRelativeResize="0"/>
           <p:nvPr/>
         </p:nvPicPr>
         <p:blipFill>
-          <a:blip r:embed="rId4">
+          <a:blip r:embed="rId3">
             <a:alphaModFix/>
           </a:blip>
           <a:stretch>
@@ -7684,7 +7655,7 @@
           <p:nvPr/>
         </p:nvPicPr>
         <p:blipFill>
-          <a:blip r:embed="rId5">
+          <a:blip r:embed="rId4">
             <a:extLst>
               <a:ext uri="{28A0092B-C50C-407E-A947-70E740481C1C}">
                 <a14:useLocalDpi xmlns:a14="http://schemas.microsoft.com/office/drawing/2010/main" val="0"/>
@@ -7714,6 +7685,36 @@
               </a14:hiddenFill>
             </a:ext>
           </a:extLst>
+        </p:spPr>
+      </p:pic>
+      <p:pic>
+        <p:nvPicPr>
+          <p:cNvPr id="5" name="Image 4">
+            <a:extLst>
+              <a:ext uri="{FF2B5EF4-FFF2-40B4-BE49-F238E27FC236}">
+                <a16:creationId xmlns:a16="http://schemas.microsoft.com/office/drawing/2014/main" id="{E21B5E2F-53A3-100A-ED5F-7E2A2F038C55}"/>
+              </a:ext>
+            </a:extLst>
+          </p:cNvPr>
+          <p:cNvPicPr>
+            <a:picLocks noChangeAspect="1"/>
+          </p:cNvPicPr>
+          <p:nvPr/>
+        </p:nvPicPr>
+        <p:blipFill>
+          <a:blip r:embed="rId5"/>
+          <a:stretch>
+            <a:fillRect/>
+          </a:stretch>
+        </p:blipFill>
+        <p:spPr>
+          <a:xfrm>
+            <a:off x="985351" y="216715"/>
+            <a:ext cx="7770685" cy="4376525"/>
+          </a:xfrm>
+          <a:prstGeom prst="rect">
+            <a:avLst/>
+          </a:prstGeom>
         </p:spPr>
       </p:pic>
     </p:spTree>

</xml_diff>